<commit_message>
Use English name across public project
</commit_message>
<xml_diff>
--- a/deliverables/Roborock东南亚市场进入研究_新加坡_GTM_2026.pptx
+++ b/deliverables/Roborock东南亚市场进入研究_新加坡_GTM_2026.pptx
@@ -2,20 +2,20 @@
 <file path=ppt/presentation.xml><?xml version="1.0" encoding="utf-8"?>
 <p:presentation xmlns:p="http://schemas.openxmlformats.org/presentationml/2006/main">
   <p:sldMasterIdLst>
-    <p:sldMasterId xmlns:r="http://schemas.openxmlformats.org/officeDocument/2006/relationships" id="2147483648" r:id="R30ef57782359458a"/>
+    <p:sldMasterId xmlns:r="http://schemas.openxmlformats.org/officeDocument/2006/relationships" id="2147483648" r:id="R724a80881cd34848"/>
   </p:sldMasterIdLst>
   <p:notesMasterIdLst>
-    <p:notesMasterId xmlns:r="http://schemas.openxmlformats.org/officeDocument/2006/relationships" r:id="R167e18156da64ba9"/>
+    <p:notesMasterId xmlns:r="http://schemas.openxmlformats.org/officeDocument/2006/relationships" r:id="R19e018df1ede4f33"/>
   </p:notesMasterIdLst>
   <p:sldIdLst>
-    <p:sldId xmlns:r="http://schemas.openxmlformats.org/officeDocument/2006/relationships" id="256" r:id="R7793856c0b4b4044"/>
-    <p:sldId xmlns:r="http://schemas.openxmlformats.org/officeDocument/2006/relationships" id="257" r:id="R83d7a73e303442c8"/>
-    <p:sldId xmlns:r="http://schemas.openxmlformats.org/officeDocument/2006/relationships" id="258" r:id="R4efba2ae1f054bdd"/>
-    <p:sldId xmlns:r="http://schemas.openxmlformats.org/officeDocument/2006/relationships" id="259" r:id="R38dd5c31f7d94951"/>
-    <p:sldId xmlns:r="http://schemas.openxmlformats.org/officeDocument/2006/relationships" id="260" r:id="R34ce051df6a54284"/>
-    <p:sldId xmlns:r="http://schemas.openxmlformats.org/officeDocument/2006/relationships" id="261" r:id="Rc5a85577b8db450b"/>
-    <p:sldId xmlns:r="http://schemas.openxmlformats.org/officeDocument/2006/relationships" id="262" r:id="Rddca91d5846344e3"/>
-    <p:sldId xmlns:r="http://schemas.openxmlformats.org/officeDocument/2006/relationships" id="263" r:id="Rac310c20f3284483"/>
+    <p:sldId xmlns:r="http://schemas.openxmlformats.org/officeDocument/2006/relationships" id="256" r:id="R2879319008a445ef"/>
+    <p:sldId xmlns:r="http://schemas.openxmlformats.org/officeDocument/2006/relationships" id="257" r:id="R84ced0c5a21c4a5a"/>
+    <p:sldId xmlns:r="http://schemas.openxmlformats.org/officeDocument/2006/relationships" id="258" r:id="Ra1613c2ef5e34d90"/>
+    <p:sldId xmlns:r="http://schemas.openxmlformats.org/officeDocument/2006/relationships" id="259" r:id="Radb11519b8804863"/>
+    <p:sldId xmlns:r="http://schemas.openxmlformats.org/officeDocument/2006/relationships" id="260" r:id="R0189d4e6009842f1"/>
+    <p:sldId xmlns:r="http://schemas.openxmlformats.org/officeDocument/2006/relationships" id="261" r:id="R00666587cd8948eb"/>
+    <p:sldId xmlns:r="http://schemas.openxmlformats.org/officeDocument/2006/relationships" id="262" r:id="R356b25de7144437a"/>
+    <p:sldId xmlns:r="http://schemas.openxmlformats.org/officeDocument/2006/relationships" id="263" r:id="R9eb18957df8e4011"/>
   </p:sldIdLst>
   <p:sldSz cx="12192000" cy="6858000"/>
   <p:notesSz cx="6858000" cy="9144000"/>
@@ -1232,7 +1232,7 @@
   </p:cSld>
   <p:clrMap bg1="lt1" tx1="dk1" bg2="lt2" tx2="dk2" accent1="accent1" accent2="accent2" accent3="accent3" accent4="accent4" accent5="accent5" accent6="accent6" hlink="hlink" folHlink="folHlink"/>
   <p:sldLayoutIdLst>
-    <p:sldLayoutId xmlns:r="http://schemas.openxmlformats.org/officeDocument/2006/relationships" id="2147483649" r:id="R61eb3589829e4628"/>
+    <p:sldLayoutId xmlns:r="http://schemas.openxmlformats.org/officeDocument/2006/relationships" id="2147483649" r:id="R62ef2d3a495e4e68"/>
   </p:sldLayoutIdLst>
   <p:txStyles>
     <p:titleStyle>
@@ -1780,14 +1780,14 @@
       </p:grpSpPr>
       <p:pic>
         <p:nvPicPr>
-          <p:cNvPr id="15" name=""/>
+          <p:cNvPr id="35" name=""/>
           <p:cNvPicPr>
             <a:picLocks xmlns:a="http://schemas.openxmlformats.org/drawingml/2006/main" noChangeAspect="1"/>
           </p:cNvPicPr>
           <p:nvPr/>
         </p:nvPicPr>
         <p:blipFill>
-          <a:blip xmlns:r="http://schemas.openxmlformats.org/officeDocument/2006/relationships" xmlns:a="http://schemas.openxmlformats.org/drawingml/2006/main" r:embed="R047e1a96821c4967"/>
+          <a:blip xmlns:r="http://schemas.openxmlformats.org/officeDocument/2006/relationships" xmlns:a="http://schemas.openxmlformats.org/drawingml/2006/main" r:embed="R40992f2d3e71418a"/>
           <a:srcRect xmlns:a="http://schemas.openxmlformats.org/drawingml/2006/main" l="0" t="7813" r="0" b="7813"/>
           <a:stretch xmlns:a="http://schemas.openxmlformats.org/drawingml/2006/main">
             <a:fillRect l="0" t="0" r="0" b="0"/>
@@ -1871,7 +1871,7 @@
       </p:sp>
       <p:cxnSp>
         <p:nvCxnSpPr>
-          <p:cNvPr id="18" name=""/>
+          <p:cNvPr id="38" name=""/>
           <p:cNvCxnSpPr/>
           <p:nvPr/>
         </p:nvCxnSpPr>
@@ -1954,6 +1954,7 @@
           <a:lstStyle xmlns:a="http://schemas.openxmlformats.org/drawingml/2006/main"/>
           <a:p xmlns:a="http://schemas.openxmlformats.org/drawingml/2006/main">
             <a:pPr algn="l">
+              <a:buNone/>
               <a:defRPr sz="975" b="1" i="0">
                 <a:solidFill>
                   <a:srgbClr val="C85034"/>
@@ -1999,6 +2000,7 @@
           <a:lstStyle xmlns:a="http://schemas.openxmlformats.org/drawingml/2006/main"/>
           <a:p xmlns:a="http://schemas.openxmlformats.org/drawingml/2006/main">
             <a:pPr algn="l">
+              <a:buNone/>
               <a:defRPr sz="4650" b="0" i="0">
                 <a:solidFill>
                   <a:srgbClr val="102F28"/>
@@ -2045,6 +2047,7 @@
           <a:lstStyle xmlns:a="http://schemas.openxmlformats.org/drawingml/2006/main"/>
           <a:p xmlns:a="http://schemas.openxmlformats.org/drawingml/2006/main">
             <a:pPr algn="l">
+              <a:buNone/>
               <a:defRPr sz="2250" b="1" i="0">
                 <a:solidFill>
                   <a:srgbClr val="1C6655"/>
@@ -2062,7 +2065,7 @@
       </p:sp>
       <p:cxnSp>
         <p:nvCxnSpPr>
-          <p:cNvPr id="23" name=""/>
+          <p:cNvPr id="43" name=""/>
           <p:cNvCxnSpPr/>
           <p:nvPr/>
         </p:nvCxnSpPr>
@@ -2112,6 +2115,7 @@
           <a:lstStyle xmlns:a="http://schemas.openxmlformats.org/drawingml/2006/main"/>
           <a:p xmlns:a="http://schemas.openxmlformats.org/drawingml/2006/main">
             <a:pPr algn="l">
+              <a:buNone/>
               <a:defRPr sz="1200" b="1" i="0">
                 <a:solidFill>
                   <a:srgbClr val="C85034"/>
@@ -2157,6 +2161,7 @@
           <a:lstStyle xmlns:a="http://schemas.openxmlformats.org/drawingml/2006/main"/>
           <a:p xmlns:a="http://schemas.openxmlformats.org/drawingml/2006/main">
             <a:pPr algn="l">
+              <a:buNone/>
               <a:defRPr sz="2025" b="1" i="0">
                 <a:solidFill>
                   <a:srgbClr val="102F28"/>
@@ -2202,6 +2207,7 @@
           <a:lstStyle xmlns:a="http://schemas.openxmlformats.org/drawingml/2006/main"/>
           <a:p xmlns:a="http://schemas.openxmlformats.org/drawingml/2006/main">
             <a:pPr algn="l">
+              <a:buNone/>
               <a:defRPr sz="1350" b="1" i="0">
                 <a:solidFill>
                   <a:srgbClr val="102F28"/>
@@ -2212,7 +2218,7 @@
               </a:defRPr>
             </a:pPr>
             <a:r>
-              <a:t>Grace 汤夏禛</a:t>
+              <a:t>Grace Tang</a:t>
             </a:r>
           </a:p>
         </p:txBody>
@@ -2247,6 +2253,7 @@
           <a:lstStyle xmlns:a="http://schemas.openxmlformats.org/drawingml/2006/main"/>
           <a:p xmlns:a="http://schemas.openxmlformats.org/drawingml/2006/main">
             <a:pPr algn="l">
+              <a:buNone/>
               <a:defRPr sz="1013" b="0" i="0">
                 <a:solidFill>
                   <a:srgbClr val="65716B"/>
@@ -2292,6 +2299,7 @@
           <a:lstStyle xmlns:a="http://schemas.openxmlformats.org/drawingml/2006/main"/>
           <a:p xmlns:a="http://schemas.openxmlformats.org/drawingml/2006/main">
             <a:pPr algn="r">
+              <a:buNone/>
               <a:defRPr sz="713" b="0" i="0">
                 <a:solidFill>
                   <a:srgbClr val="65716B"/>
@@ -2366,6 +2374,7 @@
           <a:lstStyle xmlns:a="http://schemas.openxmlformats.org/drawingml/2006/main"/>
           <a:p xmlns:a="http://schemas.openxmlformats.org/drawingml/2006/main">
             <a:pPr algn="l">
+              <a:buNone/>
               <a:defRPr sz="900" b="1" i="0">
                 <a:solidFill>
                   <a:srgbClr val="C85034"/>
@@ -2411,6 +2420,7 @@
           <a:lstStyle xmlns:a="http://schemas.openxmlformats.org/drawingml/2006/main"/>
           <a:p xmlns:a="http://schemas.openxmlformats.org/drawingml/2006/main">
             <a:pPr algn="l">
+              <a:buNone/>
               <a:defRPr sz="3225" b="0" i="0">
                 <a:solidFill>
                   <a:srgbClr val="102F28"/>
@@ -2428,7 +2438,7 @@
       </p:sp>
       <p:cxnSp>
         <p:nvCxnSpPr>
-          <p:cNvPr id="31" name=""/>
+          <p:cNvPr id="49" name=""/>
           <p:cNvCxnSpPr/>
           <p:nvPr/>
         </p:nvCxnSpPr>
@@ -2478,6 +2488,7 @@
           <a:lstStyle xmlns:a="http://schemas.openxmlformats.org/drawingml/2006/main"/>
           <a:p xmlns:a="http://schemas.openxmlformats.org/drawingml/2006/main">
             <a:pPr algn="l">
+              <a:buNone/>
               <a:defRPr sz="788" b="0" i="0">
                 <a:solidFill>
                   <a:srgbClr val="65716B"/>
@@ -2523,6 +2534,7 @@
           <a:lstStyle xmlns:a="http://schemas.openxmlformats.org/drawingml/2006/main"/>
           <a:p xmlns:a="http://schemas.openxmlformats.org/drawingml/2006/main">
             <a:pPr algn="r">
+              <a:buNone/>
               <a:defRPr sz="900" b="0" i="0">
                 <a:solidFill>
                   <a:srgbClr val="C85034"/>
@@ -2568,6 +2580,7 @@
           <a:lstStyle xmlns:a="http://schemas.openxmlformats.org/drawingml/2006/main"/>
           <a:p xmlns:a="http://schemas.openxmlformats.org/drawingml/2006/main">
             <a:pPr algn="l">
+              <a:buNone/>
               <a:defRPr sz="5100" b="0" i="0">
                 <a:solidFill>
                   <a:srgbClr val="1C6655"/>
@@ -2613,6 +2626,7 @@
           <a:lstStyle xmlns:a="http://schemas.openxmlformats.org/drawingml/2006/main"/>
           <a:p xmlns:a="http://schemas.openxmlformats.org/drawingml/2006/main">
             <a:pPr algn="l">
+              <a:buNone/>
               <a:defRPr sz="1575" b="1" i="0">
                 <a:solidFill>
                   <a:srgbClr val="102F28"/>
@@ -2658,6 +2672,7 @@
           <a:lstStyle xmlns:a="http://schemas.openxmlformats.org/drawingml/2006/main"/>
           <a:p xmlns:a="http://schemas.openxmlformats.org/drawingml/2006/main">
             <a:pPr algn="l">
+              <a:buNone/>
               <a:defRPr sz="1425" b="0" i="0">
                 <a:solidFill>
                   <a:srgbClr val="65716B"/>
@@ -2675,7 +2690,7 @@
       </p:sp>
       <p:cxnSp>
         <p:nvCxnSpPr>
-          <p:cNvPr id="37" name=""/>
+          <p:cNvPr id="55" name=""/>
           <p:cNvCxnSpPr/>
           <p:nvPr/>
         </p:nvCxnSpPr>
@@ -2725,6 +2740,7 @@
           <a:lstStyle xmlns:a="http://schemas.openxmlformats.org/drawingml/2006/main"/>
           <a:p xmlns:a="http://schemas.openxmlformats.org/drawingml/2006/main">
             <a:pPr algn="l">
+              <a:buNone/>
               <a:defRPr sz="2700" b="0" i="0">
                 <a:solidFill>
                   <a:srgbClr val="102F28"/>
@@ -2770,6 +2786,7 @@
           <a:lstStyle xmlns:a="http://schemas.openxmlformats.org/drawingml/2006/main"/>
           <a:p xmlns:a="http://schemas.openxmlformats.org/drawingml/2006/main">
             <a:pPr algn="l">
+              <a:buNone/>
               <a:defRPr sz="1200" b="0" i="0">
                 <a:solidFill>
                   <a:srgbClr val="65716B"/>
@@ -2815,6 +2832,7 @@
           <a:lstStyle xmlns:a="http://schemas.openxmlformats.org/drawingml/2006/main"/>
           <a:p xmlns:a="http://schemas.openxmlformats.org/drawingml/2006/main">
             <a:pPr algn="l">
+              <a:buNone/>
               <a:defRPr sz="2700" b="0" i="0">
                 <a:solidFill>
                   <a:srgbClr val="C85034"/>
@@ -2860,6 +2878,7 @@
           <a:lstStyle xmlns:a="http://schemas.openxmlformats.org/drawingml/2006/main"/>
           <a:p xmlns:a="http://schemas.openxmlformats.org/drawingml/2006/main">
             <a:pPr algn="l">
+              <a:buNone/>
               <a:defRPr sz="1200" b="0" i="0">
                 <a:solidFill>
                   <a:srgbClr val="65716B"/>
@@ -2905,6 +2924,7 @@
           <a:lstStyle xmlns:a="http://schemas.openxmlformats.org/drawingml/2006/main"/>
           <a:p xmlns:a="http://schemas.openxmlformats.org/drawingml/2006/main">
             <a:pPr algn="l">
+              <a:buNone/>
               <a:defRPr sz="1650" b="1" i="0">
                 <a:solidFill>
                   <a:srgbClr val="C85034"/>
@@ -2983,6 +3003,7 @@
           <a:lstStyle xmlns:a="http://schemas.openxmlformats.org/drawingml/2006/main"/>
           <a:p xmlns:a="http://schemas.openxmlformats.org/drawingml/2006/main">
             <a:pPr algn="l">
+              <a:buNone/>
               <a:defRPr sz="1650" b="1" i="0">
                 <a:solidFill>
                   <a:srgbClr val="F3EFE5"/>
@@ -3028,6 +3049,7 @@
           <a:lstStyle xmlns:a="http://schemas.openxmlformats.org/drawingml/2006/main"/>
           <a:p xmlns:a="http://schemas.openxmlformats.org/drawingml/2006/main">
             <a:pPr algn="l">
+              <a:buNone/>
               <a:defRPr sz="2100" b="1" i="0">
                 <a:solidFill>
                   <a:srgbClr val="F3EFE5"/>
@@ -3073,6 +3095,7 @@
           <a:lstStyle xmlns:a="http://schemas.openxmlformats.org/drawingml/2006/main"/>
           <a:p xmlns:a="http://schemas.openxmlformats.org/drawingml/2006/main">
             <a:pPr algn="l">
+              <a:buNone/>
               <a:defRPr sz="1050" b="0" i="0">
                 <a:solidFill>
                   <a:srgbClr val="F3EFE5"/>
@@ -3151,6 +3174,7 @@
           <a:lstStyle xmlns:a="http://schemas.openxmlformats.org/drawingml/2006/main"/>
           <a:p xmlns:a="http://schemas.openxmlformats.org/drawingml/2006/main">
             <a:pPr algn="l">
+              <a:buNone/>
               <a:defRPr sz="1650" b="1" i="0">
                 <a:solidFill>
                   <a:srgbClr val="102F28"/>
@@ -3196,6 +3220,7 @@
           <a:lstStyle xmlns:a="http://schemas.openxmlformats.org/drawingml/2006/main"/>
           <a:p xmlns:a="http://schemas.openxmlformats.org/drawingml/2006/main">
             <a:pPr algn="l">
+              <a:buNone/>
               <a:defRPr sz="2025" b="1" i="0">
                 <a:solidFill>
                   <a:srgbClr val="102F28"/>
@@ -3241,6 +3266,7 @@
           <a:lstStyle xmlns:a="http://schemas.openxmlformats.org/drawingml/2006/main"/>
           <a:p xmlns:a="http://schemas.openxmlformats.org/drawingml/2006/main">
             <a:pPr algn="l">
+              <a:buNone/>
               <a:defRPr sz="1050" b="0" i="0">
                 <a:solidFill>
                   <a:srgbClr val="65716B"/>
@@ -3319,6 +3345,7 @@
           <a:lstStyle xmlns:a="http://schemas.openxmlformats.org/drawingml/2006/main"/>
           <a:p xmlns:a="http://schemas.openxmlformats.org/drawingml/2006/main">
             <a:pPr algn="l">
+              <a:buNone/>
               <a:defRPr sz="1650" b="1" i="0">
                 <a:solidFill>
                   <a:srgbClr val="102F28"/>
@@ -3364,6 +3391,7 @@
           <a:lstStyle xmlns:a="http://schemas.openxmlformats.org/drawingml/2006/main"/>
           <a:p xmlns:a="http://schemas.openxmlformats.org/drawingml/2006/main">
             <a:pPr algn="l">
+              <a:buNone/>
               <a:defRPr sz="2025" b="1" i="0">
                 <a:solidFill>
                   <a:srgbClr val="102F28"/>
@@ -3409,6 +3437,7 @@
           <a:lstStyle xmlns:a="http://schemas.openxmlformats.org/drawingml/2006/main"/>
           <a:p xmlns:a="http://schemas.openxmlformats.org/drawingml/2006/main">
             <a:pPr algn="l">
+              <a:buNone/>
               <a:defRPr sz="1050" b="0" i="0">
                 <a:solidFill>
                   <a:srgbClr val="65716B"/>
@@ -3487,6 +3516,7 @@
           <a:lstStyle xmlns:a="http://schemas.openxmlformats.org/drawingml/2006/main"/>
           <a:p xmlns:a="http://schemas.openxmlformats.org/drawingml/2006/main">
             <a:pPr algn="ctr">
+              <a:buNone/>
               <a:defRPr sz="1575" b="1" i="0">
                 <a:solidFill>
                   <a:srgbClr val="F3EFE5"/>
@@ -3561,6 +3591,7 @@
           <a:lstStyle xmlns:a="http://schemas.openxmlformats.org/drawingml/2006/main"/>
           <a:p xmlns:a="http://schemas.openxmlformats.org/drawingml/2006/main">
             <a:pPr algn="l">
+              <a:buNone/>
               <a:defRPr sz="900" b="1" i="0">
                 <a:solidFill>
                   <a:srgbClr val="C85034"/>
@@ -3606,6 +3637,7 @@
           <a:lstStyle xmlns:a="http://schemas.openxmlformats.org/drawingml/2006/main"/>
           <a:p xmlns:a="http://schemas.openxmlformats.org/drawingml/2006/main">
             <a:pPr algn="l">
+              <a:buNone/>
               <a:defRPr sz="3225" b="0" i="0">
                 <a:solidFill>
                   <a:srgbClr val="102F28"/>
@@ -3623,7 +3655,7 @@
       </p:sp>
       <p:cxnSp>
         <p:nvCxnSpPr>
-          <p:cNvPr id="32" name=""/>
+          <p:cNvPr id="70" name=""/>
           <p:cNvCxnSpPr/>
           <p:nvPr/>
         </p:nvCxnSpPr>
@@ -3673,6 +3705,7 @@
           <a:lstStyle xmlns:a="http://schemas.openxmlformats.org/drawingml/2006/main"/>
           <a:p xmlns:a="http://schemas.openxmlformats.org/drawingml/2006/main">
             <a:pPr algn="l">
+              <a:buNone/>
               <a:defRPr sz="788" b="0" i="0">
                 <a:solidFill>
                   <a:srgbClr val="65716B"/>
@@ -3718,6 +3751,7 @@
           <a:lstStyle xmlns:a="http://schemas.openxmlformats.org/drawingml/2006/main"/>
           <a:p xmlns:a="http://schemas.openxmlformats.org/drawingml/2006/main">
             <a:pPr algn="r">
+              <a:buNone/>
               <a:defRPr sz="900" b="0" i="0">
                 <a:solidFill>
                   <a:srgbClr val="C85034"/>
@@ -3763,6 +3797,7 @@
           <a:lstStyle xmlns:a="http://schemas.openxmlformats.org/drawingml/2006/main"/>
           <a:p xmlns:a="http://schemas.openxmlformats.org/drawingml/2006/main">
             <a:pPr algn="l">
+              <a:buNone/>
               <a:defRPr sz="2700" b="0" i="0">
                 <a:solidFill>
                   <a:srgbClr val="C85034"/>
@@ -3808,6 +3843,7 @@
           <a:lstStyle xmlns:a="http://schemas.openxmlformats.org/drawingml/2006/main"/>
           <a:p xmlns:a="http://schemas.openxmlformats.org/drawingml/2006/main">
             <a:pPr algn="l">
+              <a:buNone/>
               <a:defRPr sz="2250" b="1" i="0">
                 <a:solidFill>
                   <a:srgbClr val="102F28"/>
@@ -3825,7 +3861,7 @@
       </p:sp>
       <p:cxnSp>
         <p:nvCxnSpPr>
-          <p:cNvPr id="37" name=""/>
+          <p:cNvPr id="75" name=""/>
           <p:cNvCxnSpPr/>
           <p:nvPr/>
         </p:nvCxnSpPr>
@@ -3875,6 +3911,7 @@
           <a:lstStyle xmlns:a="http://schemas.openxmlformats.org/drawingml/2006/main"/>
           <a:p xmlns:a="http://schemas.openxmlformats.org/drawingml/2006/main">
             <a:pPr algn="l">
+              <a:buNone/>
               <a:defRPr sz="1350" b="1" i="0">
                 <a:solidFill>
                   <a:srgbClr val="1C6655"/>
@@ -3920,6 +3957,7 @@
           <a:lstStyle xmlns:a="http://schemas.openxmlformats.org/drawingml/2006/main"/>
           <a:p xmlns:a="http://schemas.openxmlformats.org/drawingml/2006/main">
             <a:pPr algn="l">
+              <a:buNone/>
               <a:defRPr sz="1800" b="1" i="0">
                 <a:solidFill>
                   <a:srgbClr val="102F28"/>
@@ -3965,6 +4003,7 @@
           <a:lstStyle xmlns:a="http://schemas.openxmlformats.org/drawingml/2006/main"/>
           <a:p xmlns:a="http://schemas.openxmlformats.org/drawingml/2006/main">
             <a:pPr algn="l">
+              <a:buNone/>
               <a:defRPr sz="1350" b="1" i="0">
                 <a:solidFill>
                   <a:srgbClr val="C85034"/>
@@ -4010,6 +4049,7 @@
           <a:lstStyle xmlns:a="http://schemas.openxmlformats.org/drawingml/2006/main"/>
           <a:p xmlns:a="http://schemas.openxmlformats.org/drawingml/2006/main">
             <a:pPr algn="l">
+              <a:buNone/>
               <a:defRPr sz="1800" b="1" i="0">
                 <a:solidFill>
                   <a:srgbClr val="102F28"/>
@@ -4055,6 +4095,7 @@
           <a:lstStyle xmlns:a="http://schemas.openxmlformats.org/drawingml/2006/main"/>
           <a:p xmlns:a="http://schemas.openxmlformats.org/drawingml/2006/main">
             <a:pPr algn="l">
+              <a:buNone/>
               <a:defRPr sz="1350" b="1" i="0">
                 <a:solidFill>
                   <a:srgbClr val="65716B"/>
@@ -4100,6 +4141,7 @@
           <a:lstStyle xmlns:a="http://schemas.openxmlformats.org/drawingml/2006/main"/>
           <a:p xmlns:a="http://schemas.openxmlformats.org/drawingml/2006/main">
             <a:pPr algn="l">
+              <a:buNone/>
               <a:defRPr sz="1500" b="0" i="0">
                 <a:solidFill>
                   <a:srgbClr val="65716B"/>
@@ -4178,6 +4220,7 @@
           <a:lstStyle xmlns:a="http://schemas.openxmlformats.org/drawingml/2006/main"/>
           <a:p xmlns:a="http://schemas.openxmlformats.org/drawingml/2006/main">
             <a:pPr algn="ctr">
+              <a:buNone/>
               <a:defRPr sz="1388" b="1" i="0">
                 <a:solidFill>
                   <a:srgbClr val="1C6655"/>
@@ -4223,6 +4266,7 @@
           <a:lstStyle xmlns:a="http://schemas.openxmlformats.org/drawingml/2006/main"/>
           <a:p xmlns:a="http://schemas.openxmlformats.org/drawingml/2006/main">
             <a:pPr algn="l">
+              <a:buNone/>
               <a:defRPr sz="2700" b="0" i="0">
                 <a:solidFill>
                   <a:srgbClr val="C85034"/>
@@ -4268,6 +4312,7 @@
           <a:lstStyle xmlns:a="http://schemas.openxmlformats.org/drawingml/2006/main"/>
           <a:p xmlns:a="http://schemas.openxmlformats.org/drawingml/2006/main">
             <a:pPr algn="l">
+              <a:buNone/>
               <a:defRPr sz="2250" b="1" i="0">
                 <a:solidFill>
                   <a:srgbClr val="102F28"/>
@@ -4285,7 +4330,7 @@
       </p:sp>
       <p:cxnSp>
         <p:nvCxnSpPr>
-          <p:cNvPr id="48" name=""/>
+          <p:cNvPr id="86" name=""/>
           <p:cNvCxnSpPr/>
           <p:nvPr/>
         </p:nvCxnSpPr>
@@ -4335,6 +4380,7 @@
           <a:lstStyle xmlns:a="http://schemas.openxmlformats.org/drawingml/2006/main"/>
           <a:p xmlns:a="http://schemas.openxmlformats.org/drawingml/2006/main">
             <a:pPr algn="l">
+              <a:buNone/>
               <a:defRPr sz="1350" b="1" i="0">
                 <a:solidFill>
                   <a:srgbClr val="1C6655"/>
@@ -4380,6 +4426,7 @@
           <a:lstStyle xmlns:a="http://schemas.openxmlformats.org/drawingml/2006/main"/>
           <a:p xmlns:a="http://schemas.openxmlformats.org/drawingml/2006/main">
             <a:pPr algn="l">
+              <a:buNone/>
               <a:defRPr sz="1800" b="1" i="0">
                 <a:solidFill>
                   <a:srgbClr val="102F28"/>
@@ -4425,6 +4472,7 @@
           <a:lstStyle xmlns:a="http://schemas.openxmlformats.org/drawingml/2006/main"/>
           <a:p xmlns:a="http://schemas.openxmlformats.org/drawingml/2006/main">
             <a:pPr algn="l">
+              <a:buNone/>
               <a:defRPr sz="1350" b="1" i="0">
                 <a:solidFill>
                   <a:srgbClr val="C85034"/>
@@ -4470,6 +4518,7 @@
           <a:lstStyle xmlns:a="http://schemas.openxmlformats.org/drawingml/2006/main"/>
           <a:p xmlns:a="http://schemas.openxmlformats.org/drawingml/2006/main">
             <a:pPr algn="l">
+              <a:buNone/>
               <a:defRPr sz="1800" b="1" i="0">
                 <a:solidFill>
                   <a:srgbClr val="102F28"/>
@@ -4515,6 +4564,7 @@
           <a:lstStyle xmlns:a="http://schemas.openxmlformats.org/drawingml/2006/main"/>
           <a:p xmlns:a="http://schemas.openxmlformats.org/drawingml/2006/main">
             <a:pPr algn="l">
+              <a:buNone/>
               <a:defRPr sz="1350" b="1" i="0">
                 <a:solidFill>
                   <a:srgbClr val="65716B"/>
@@ -4560,6 +4610,7 @@
           <a:lstStyle xmlns:a="http://schemas.openxmlformats.org/drawingml/2006/main"/>
           <a:p xmlns:a="http://schemas.openxmlformats.org/drawingml/2006/main">
             <a:pPr algn="l">
+              <a:buNone/>
               <a:defRPr sz="1500" b="0" i="0">
                 <a:solidFill>
                   <a:srgbClr val="65716B"/>
@@ -4638,6 +4689,7 @@
           <a:lstStyle xmlns:a="http://schemas.openxmlformats.org/drawingml/2006/main"/>
           <a:p xmlns:a="http://schemas.openxmlformats.org/drawingml/2006/main">
             <a:pPr algn="ctr">
+              <a:buNone/>
               <a:defRPr sz="1388" b="1" i="0">
                 <a:solidFill>
                   <a:srgbClr val="1C6655"/>
@@ -4716,6 +4768,7 @@
           <a:lstStyle xmlns:a="http://schemas.openxmlformats.org/drawingml/2006/main"/>
           <a:p xmlns:a="http://schemas.openxmlformats.org/drawingml/2006/main">
             <a:pPr algn="ctr">
+              <a:buNone/>
               <a:defRPr sz="1650" b="1" i="0">
                 <a:solidFill>
                   <a:srgbClr val="F3EFE5"/>
@@ -4790,6 +4843,7 @@
           <a:lstStyle xmlns:a="http://schemas.openxmlformats.org/drawingml/2006/main"/>
           <a:p xmlns:a="http://schemas.openxmlformats.org/drawingml/2006/main">
             <a:pPr algn="l">
+              <a:buNone/>
               <a:defRPr sz="900" b="1" i="0">
                 <a:solidFill>
                   <a:srgbClr val="C85034"/>
@@ -4835,6 +4889,7 @@
           <a:lstStyle xmlns:a="http://schemas.openxmlformats.org/drawingml/2006/main"/>
           <a:p xmlns:a="http://schemas.openxmlformats.org/drawingml/2006/main">
             <a:pPr algn="l">
+              <a:buNone/>
               <a:defRPr sz="3225" b="0" i="0">
                 <a:solidFill>
                   <a:srgbClr val="102F28"/>
@@ -4852,7 +4907,7 @@
       </p:sp>
       <p:cxnSp>
         <p:nvCxnSpPr>
-          <p:cNvPr id="34" name=""/>
+          <p:cNvPr id="40" name=""/>
           <p:cNvCxnSpPr/>
           <p:nvPr/>
         </p:nvCxnSpPr>
@@ -4902,6 +4957,7 @@
           <a:lstStyle xmlns:a="http://schemas.openxmlformats.org/drawingml/2006/main"/>
           <a:p xmlns:a="http://schemas.openxmlformats.org/drawingml/2006/main">
             <a:pPr algn="l">
+              <a:buNone/>
               <a:defRPr sz="788" b="0" i="0">
                 <a:solidFill>
                   <a:srgbClr val="65716B"/>
@@ -4947,6 +5003,7 @@
           <a:lstStyle xmlns:a="http://schemas.openxmlformats.org/drawingml/2006/main"/>
           <a:p xmlns:a="http://schemas.openxmlformats.org/drawingml/2006/main">
             <a:pPr algn="r">
+              <a:buNone/>
               <a:defRPr sz="900" b="0" i="0">
                 <a:solidFill>
                   <a:srgbClr val="C85034"/>
@@ -4992,6 +5049,7 @@
           <a:lstStyle xmlns:a="http://schemas.openxmlformats.org/drawingml/2006/main"/>
           <a:p xmlns:a="http://schemas.openxmlformats.org/drawingml/2006/main">
             <a:pPr algn="l">
+              <a:buNone/>
               <a:defRPr sz="1125" b="1" i="0">
                 <a:solidFill>
                   <a:srgbClr val="C85034"/>
@@ -5037,6 +5095,7 @@
           <a:lstStyle xmlns:a="http://schemas.openxmlformats.org/drawingml/2006/main"/>
           <a:p xmlns:a="http://schemas.openxmlformats.org/drawingml/2006/main">
             <a:pPr algn="l">
+              <a:buNone/>
               <a:defRPr sz="1125" b="1" i="0">
                 <a:solidFill>
                   <a:srgbClr val="C85034"/>
@@ -5082,6 +5141,7 @@
           <a:lstStyle xmlns:a="http://schemas.openxmlformats.org/drawingml/2006/main"/>
           <a:p xmlns:a="http://schemas.openxmlformats.org/drawingml/2006/main">
             <a:pPr algn="l">
+              <a:buNone/>
               <a:defRPr sz="1125" b="1" i="0">
                 <a:solidFill>
                   <a:srgbClr val="C85034"/>
@@ -5127,6 +5187,7 @@
           <a:lstStyle xmlns:a="http://schemas.openxmlformats.org/drawingml/2006/main"/>
           <a:p xmlns:a="http://schemas.openxmlformats.org/drawingml/2006/main">
             <a:pPr algn="l">
+              <a:buNone/>
               <a:defRPr sz="1125" b="1" i="0">
                 <a:solidFill>
                   <a:srgbClr val="C85034"/>
@@ -5205,6 +5266,7 @@
           <a:lstStyle xmlns:a="http://schemas.openxmlformats.org/drawingml/2006/main"/>
           <a:p xmlns:a="http://schemas.openxmlformats.org/drawingml/2006/main">
             <a:pPr algn="l">
+              <a:buNone/>
               <a:defRPr sz="1950" b="1" i="0">
                 <a:solidFill>
                   <a:srgbClr val="102F28"/>
@@ -5250,6 +5312,7 @@
           <a:lstStyle xmlns:a="http://schemas.openxmlformats.org/drawingml/2006/main"/>
           <a:p xmlns:a="http://schemas.openxmlformats.org/drawingml/2006/main">
             <a:pPr algn="l">
+              <a:buNone/>
               <a:defRPr sz="2550" b="1" i="0">
                 <a:solidFill>
                   <a:srgbClr val="1C6655"/>
@@ -5295,6 +5358,7 @@
           <a:lstStyle xmlns:a="http://schemas.openxmlformats.org/drawingml/2006/main"/>
           <a:p xmlns:a="http://schemas.openxmlformats.org/drawingml/2006/main">
             <a:pPr algn="l">
+              <a:buNone/>
               <a:defRPr sz="1350" b="0" i="0">
                 <a:solidFill>
                   <a:srgbClr val="65716B"/>
@@ -5340,6 +5404,7 @@
           <a:lstStyle xmlns:a="http://schemas.openxmlformats.org/drawingml/2006/main"/>
           <a:p xmlns:a="http://schemas.openxmlformats.org/drawingml/2006/main">
             <a:pPr algn="l">
+              <a:buNone/>
               <a:defRPr sz="1500" b="1" i="0">
                 <a:solidFill>
                   <a:srgbClr val="102F28"/>
@@ -5385,6 +5450,7 @@
           <a:lstStyle xmlns:a="http://schemas.openxmlformats.org/drawingml/2006/main"/>
           <a:p xmlns:a="http://schemas.openxmlformats.org/drawingml/2006/main">
             <a:pPr algn="ctr">
+              <a:buNone/>
               <a:defRPr sz="2250" b="0" i="0">
                 <a:solidFill>
                   <a:srgbClr val="C85034"/>
@@ -5430,6 +5496,7 @@
           <a:lstStyle xmlns:a="http://schemas.openxmlformats.org/drawingml/2006/main"/>
           <a:p xmlns:a="http://schemas.openxmlformats.org/drawingml/2006/main">
             <a:pPr algn="l">
+              <a:buNone/>
               <a:defRPr sz="1575" b="1" i="0">
                 <a:solidFill>
                   <a:srgbClr val="102F28"/>
@@ -5509,6 +5576,7 @@
           <a:lstStyle xmlns:a="http://schemas.openxmlformats.org/drawingml/2006/main"/>
           <a:p xmlns:a="http://schemas.openxmlformats.org/drawingml/2006/main">
             <a:pPr algn="l">
+              <a:buNone/>
               <a:defRPr sz="1950" b="1" i="0">
                 <a:solidFill>
                   <a:srgbClr val="102F28"/>
@@ -5554,6 +5622,7 @@
           <a:lstStyle xmlns:a="http://schemas.openxmlformats.org/drawingml/2006/main"/>
           <a:p xmlns:a="http://schemas.openxmlformats.org/drawingml/2006/main">
             <a:pPr algn="l">
+              <a:buNone/>
               <a:defRPr sz="2550" b="1" i="0">
                 <a:solidFill>
                   <a:srgbClr val="1C6655"/>
@@ -5599,6 +5668,7 @@
           <a:lstStyle xmlns:a="http://schemas.openxmlformats.org/drawingml/2006/main"/>
           <a:p xmlns:a="http://schemas.openxmlformats.org/drawingml/2006/main">
             <a:pPr algn="l">
+              <a:buNone/>
               <a:defRPr sz="1350" b="0" i="0">
                 <a:solidFill>
                   <a:srgbClr val="65716B"/>
@@ -5644,6 +5714,7 @@
           <a:lstStyle xmlns:a="http://schemas.openxmlformats.org/drawingml/2006/main"/>
           <a:p xmlns:a="http://schemas.openxmlformats.org/drawingml/2006/main">
             <a:pPr algn="l">
+              <a:buNone/>
               <a:defRPr sz="1500" b="1" i="0">
                 <a:solidFill>
                   <a:srgbClr val="102F28"/>
@@ -5690,6 +5761,7 @@
           <a:lstStyle xmlns:a="http://schemas.openxmlformats.org/drawingml/2006/main"/>
           <a:p xmlns:a="http://schemas.openxmlformats.org/drawingml/2006/main">
             <a:pPr algn="ctr">
+              <a:buNone/>
               <a:defRPr sz="2250" b="0" i="0">
                 <a:solidFill>
                   <a:srgbClr val="C85034"/>
@@ -5735,6 +5807,7 @@
           <a:lstStyle xmlns:a="http://schemas.openxmlformats.org/drawingml/2006/main"/>
           <a:p xmlns:a="http://schemas.openxmlformats.org/drawingml/2006/main">
             <a:pPr algn="l">
+              <a:buNone/>
               <a:defRPr sz="1575" b="1" i="0">
                 <a:solidFill>
                   <a:srgbClr val="102F28"/>
@@ -5814,6 +5887,7 @@
           <a:lstStyle xmlns:a="http://schemas.openxmlformats.org/drawingml/2006/main"/>
           <a:p xmlns:a="http://schemas.openxmlformats.org/drawingml/2006/main">
             <a:pPr algn="l">
+              <a:buNone/>
               <a:defRPr sz="1950" b="1" i="0">
                 <a:solidFill>
                   <a:srgbClr val="F3EFE5"/>
@@ -5859,6 +5933,7 @@
           <a:lstStyle xmlns:a="http://schemas.openxmlformats.org/drawingml/2006/main"/>
           <a:p xmlns:a="http://schemas.openxmlformats.org/drawingml/2006/main">
             <a:pPr algn="l">
+              <a:buNone/>
               <a:defRPr sz="2550" b="1" i="0">
                 <a:solidFill>
                   <a:srgbClr val="F3EFE5"/>
@@ -5904,6 +5979,7 @@
           <a:lstStyle xmlns:a="http://schemas.openxmlformats.org/drawingml/2006/main"/>
           <a:p xmlns:a="http://schemas.openxmlformats.org/drawingml/2006/main">
             <a:pPr algn="l">
+              <a:buNone/>
               <a:defRPr sz="1350" b="0" i="0">
                 <a:solidFill>
                   <a:srgbClr val="F3EFE5"/>
@@ -5949,6 +6025,7 @@
           <a:lstStyle xmlns:a="http://schemas.openxmlformats.org/drawingml/2006/main"/>
           <a:p xmlns:a="http://schemas.openxmlformats.org/drawingml/2006/main">
             <a:pPr algn="l">
+              <a:buNone/>
               <a:defRPr sz="1500" b="1" i="0">
                 <a:solidFill>
                   <a:srgbClr val="F3EFE5"/>
@@ -5995,6 +6072,7 @@
           <a:lstStyle xmlns:a="http://schemas.openxmlformats.org/drawingml/2006/main"/>
           <a:p xmlns:a="http://schemas.openxmlformats.org/drawingml/2006/main">
             <a:pPr algn="ctr">
+              <a:buNone/>
               <a:defRPr sz="2250" b="0" i="0">
                 <a:solidFill>
                   <a:srgbClr val="C85034"/>
@@ -6040,6 +6118,7 @@
           <a:lstStyle xmlns:a="http://schemas.openxmlformats.org/drawingml/2006/main"/>
           <a:p xmlns:a="http://schemas.openxmlformats.org/drawingml/2006/main">
             <a:pPr algn="l">
+              <a:buNone/>
               <a:defRPr sz="1575" b="1" i="0">
                 <a:solidFill>
                   <a:srgbClr val="F3EFE5"/>
@@ -6086,6 +6165,7 @@
           <a:lstStyle xmlns:a="http://schemas.openxmlformats.org/drawingml/2006/main"/>
           <a:p xmlns:a="http://schemas.openxmlformats.org/drawingml/2006/main">
             <a:pPr algn="l">
+              <a:buNone/>
               <a:defRPr sz="1088" b="0" i="0">
                 <a:solidFill>
                   <a:srgbClr val="65716B"/>
@@ -6160,6 +6240,7 @@
           <a:lstStyle xmlns:a="http://schemas.openxmlformats.org/drawingml/2006/main"/>
           <a:p xmlns:a="http://schemas.openxmlformats.org/drawingml/2006/main">
             <a:pPr algn="l">
+              <a:buNone/>
               <a:defRPr sz="900" b="1" i="0">
                 <a:solidFill>
                   <a:srgbClr val="C85034"/>
@@ -6205,6 +6286,7 @@
           <a:lstStyle xmlns:a="http://schemas.openxmlformats.org/drawingml/2006/main"/>
           <a:p xmlns:a="http://schemas.openxmlformats.org/drawingml/2006/main">
             <a:pPr algn="l">
+              <a:buNone/>
               <a:defRPr sz="3225" b="0" i="0">
                 <a:solidFill>
                   <a:srgbClr val="102F28"/>
@@ -6222,7 +6304,7 @@
       </p:sp>
       <p:cxnSp>
         <p:nvCxnSpPr>
-          <p:cNvPr id="14" name=""/>
+          <p:cNvPr id="22" name=""/>
           <p:cNvCxnSpPr/>
           <p:nvPr/>
         </p:nvCxnSpPr>
@@ -6272,6 +6354,7 @@
           <a:lstStyle xmlns:a="http://schemas.openxmlformats.org/drawingml/2006/main"/>
           <a:p xmlns:a="http://schemas.openxmlformats.org/drawingml/2006/main">
             <a:pPr algn="l">
+              <a:buNone/>
               <a:defRPr sz="788" b="0" i="0">
                 <a:solidFill>
                   <a:srgbClr val="65716B"/>
@@ -6317,6 +6400,7 @@
           <a:lstStyle xmlns:a="http://schemas.openxmlformats.org/drawingml/2006/main"/>
           <a:p xmlns:a="http://schemas.openxmlformats.org/drawingml/2006/main">
             <a:pPr algn="r">
+              <a:buNone/>
               <a:defRPr sz="900" b="0" i="0">
                 <a:solidFill>
                   <a:srgbClr val="C85034"/>
@@ -6362,6 +6446,7 @@
           <a:lstStyle xmlns:a="http://schemas.openxmlformats.org/drawingml/2006/main"/>
           <a:p xmlns:a="http://schemas.openxmlformats.org/drawingml/2006/main">
             <a:pPr algn="l">
+              <a:buNone/>
               <a:defRPr sz="1200" b="0" i="0">
                 <a:solidFill>
                   <a:srgbClr val="65716B"/>
@@ -6379,7 +6464,7 @@
       </p:sp>
       <p:graphicFrame>
         <p:nvGraphicFramePr>
-          <p:cNvPr id="18" name=""/>
+          <p:cNvPr id="26" name=""/>
           <p:cNvGraphicFramePr/>
           <p:nvPr/>
         </p:nvGraphicFramePr>
@@ -7040,6 +7125,7 @@
           <a:lstStyle xmlns:a="http://schemas.openxmlformats.org/drawingml/2006/main"/>
           <a:p xmlns:a="http://schemas.openxmlformats.org/drawingml/2006/main">
             <a:pPr algn="l">
+              <a:buNone/>
               <a:defRPr sz="1275" b="1" i="0">
                 <a:solidFill>
                   <a:srgbClr val="F3EFE5"/>
@@ -7085,6 +7171,7 @@
           <a:lstStyle xmlns:a="http://schemas.openxmlformats.org/drawingml/2006/main"/>
           <a:p xmlns:a="http://schemas.openxmlformats.org/drawingml/2006/main">
             <a:pPr algn="l">
+              <a:buNone/>
               <a:defRPr sz="1725" b="1" i="0">
                 <a:solidFill>
                   <a:srgbClr val="F3EFE5"/>
@@ -7130,6 +7217,7 @@
           <a:lstStyle xmlns:a="http://schemas.openxmlformats.org/drawingml/2006/main"/>
           <a:p xmlns:a="http://schemas.openxmlformats.org/drawingml/2006/main">
             <a:pPr algn="r">
+              <a:buNone/>
               <a:defRPr sz="1050" b="0" i="0">
                 <a:solidFill>
                   <a:srgbClr val="F3EFE5"/>
@@ -7204,6 +7292,7 @@
           <a:lstStyle xmlns:a="http://schemas.openxmlformats.org/drawingml/2006/main"/>
           <a:p xmlns:a="http://schemas.openxmlformats.org/drawingml/2006/main">
             <a:pPr algn="l">
+              <a:buNone/>
               <a:defRPr sz="900" b="1" i="0">
                 <a:solidFill>
                   <a:srgbClr val="C85034"/>
@@ -7249,6 +7338,7 @@
           <a:lstStyle xmlns:a="http://schemas.openxmlformats.org/drawingml/2006/main"/>
           <a:p xmlns:a="http://schemas.openxmlformats.org/drawingml/2006/main">
             <a:pPr algn="l">
+              <a:buNone/>
               <a:defRPr sz="3225" b="0" i="0">
                 <a:solidFill>
                   <a:srgbClr val="102F28"/>
@@ -7266,7 +7356,7 @@
       </p:sp>
       <p:cxnSp>
         <p:nvCxnSpPr>
-          <p:cNvPr id="35" name=""/>
+          <p:cNvPr id="93" name=""/>
           <p:cNvCxnSpPr/>
           <p:nvPr/>
         </p:nvCxnSpPr>
@@ -7316,6 +7406,7 @@
           <a:lstStyle xmlns:a="http://schemas.openxmlformats.org/drawingml/2006/main"/>
           <a:p xmlns:a="http://schemas.openxmlformats.org/drawingml/2006/main">
             <a:pPr algn="l">
+              <a:buNone/>
               <a:defRPr sz="788" b="0" i="0">
                 <a:solidFill>
                   <a:srgbClr val="65716B"/>
@@ -7361,6 +7452,7 @@
           <a:lstStyle xmlns:a="http://schemas.openxmlformats.org/drawingml/2006/main"/>
           <a:p xmlns:a="http://schemas.openxmlformats.org/drawingml/2006/main">
             <a:pPr algn="r">
+              <a:buNone/>
               <a:defRPr sz="900" b="0" i="0">
                 <a:solidFill>
                   <a:srgbClr val="C85034"/>
@@ -7378,7 +7470,7 @@
       </p:sp>
       <p:cxnSp>
         <p:nvCxnSpPr>
-          <p:cNvPr id="38" name=""/>
+          <p:cNvPr id="96" name=""/>
           <p:cNvCxnSpPr/>
           <p:nvPr/>
         </p:nvCxnSpPr>
@@ -7400,7 +7492,7 @@
       </p:cxnSp>
       <p:cxnSp>
         <p:nvCxnSpPr>
-          <p:cNvPr id="39" name=""/>
+          <p:cNvPr id="97" name=""/>
           <p:cNvCxnSpPr/>
           <p:nvPr/>
         </p:nvCxnSpPr>
@@ -7422,7 +7514,7 @@
       </p:cxnSp>
       <p:cxnSp>
         <p:nvCxnSpPr>
-          <p:cNvPr id="40" name=""/>
+          <p:cNvPr id="98" name=""/>
           <p:cNvCxnSpPr/>
           <p:nvPr/>
         </p:nvCxnSpPr>
@@ -7472,6 +7564,7 @@
           <a:lstStyle xmlns:a="http://schemas.openxmlformats.org/drawingml/2006/main"/>
           <a:p xmlns:a="http://schemas.openxmlformats.org/drawingml/2006/main">
             <a:pPr algn="l">
+              <a:buNone/>
               <a:defRPr sz="1125" b="1" i="0">
                 <a:solidFill>
                   <a:srgbClr val="C85034"/>
@@ -7517,6 +7610,7 @@
           <a:lstStyle xmlns:a="http://schemas.openxmlformats.org/drawingml/2006/main"/>
           <a:p xmlns:a="http://schemas.openxmlformats.org/drawingml/2006/main">
             <a:pPr algn="l">
+              <a:buNone/>
               <a:defRPr sz="2100" b="1" i="0">
                 <a:solidFill>
                   <a:srgbClr val="102F28"/>
@@ -7562,6 +7656,7 @@
           <a:lstStyle xmlns:a="http://schemas.openxmlformats.org/drawingml/2006/main"/>
           <a:p xmlns:a="http://schemas.openxmlformats.org/drawingml/2006/main">
             <a:pPr algn="l">
+              <a:buNone/>
               <a:defRPr sz="1425" b="0" i="0">
                 <a:solidFill>
                   <a:srgbClr val="65716B"/>
@@ -7608,6 +7703,7 @@
           <a:lstStyle xmlns:a="http://schemas.openxmlformats.org/drawingml/2006/main"/>
           <a:p xmlns:a="http://schemas.openxmlformats.org/drawingml/2006/main">
             <a:pPr algn="l">
+              <a:buNone/>
               <a:defRPr sz="1125" b="1" i="0">
                 <a:solidFill>
                   <a:srgbClr val="C85034"/>
@@ -7653,6 +7749,7 @@
           <a:lstStyle xmlns:a="http://schemas.openxmlformats.org/drawingml/2006/main"/>
           <a:p xmlns:a="http://schemas.openxmlformats.org/drawingml/2006/main">
             <a:pPr algn="l">
+              <a:buNone/>
               <a:defRPr sz="2100" b="1" i="0">
                 <a:solidFill>
                   <a:srgbClr val="102F28"/>
@@ -7698,6 +7795,7 @@
           <a:lstStyle xmlns:a="http://schemas.openxmlformats.org/drawingml/2006/main"/>
           <a:p xmlns:a="http://schemas.openxmlformats.org/drawingml/2006/main">
             <a:pPr algn="l">
+              <a:buNone/>
               <a:defRPr sz="1425" b="0" i="0">
                 <a:solidFill>
                   <a:srgbClr val="65716B"/>
@@ -7744,6 +7842,7 @@
           <a:lstStyle xmlns:a="http://schemas.openxmlformats.org/drawingml/2006/main"/>
           <a:p xmlns:a="http://schemas.openxmlformats.org/drawingml/2006/main">
             <a:pPr algn="l">
+              <a:buNone/>
               <a:defRPr sz="1125" b="1" i="0">
                 <a:solidFill>
                   <a:srgbClr val="C85034"/>
@@ -7789,6 +7888,7 @@
           <a:lstStyle xmlns:a="http://schemas.openxmlformats.org/drawingml/2006/main"/>
           <a:p xmlns:a="http://schemas.openxmlformats.org/drawingml/2006/main">
             <a:pPr algn="l">
+              <a:buNone/>
               <a:defRPr sz="2100" b="1" i="0">
                 <a:solidFill>
                   <a:srgbClr val="102F28"/>
@@ -7834,6 +7934,7 @@
           <a:lstStyle xmlns:a="http://schemas.openxmlformats.org/drawingml/2006/main"/>
           <a:p xmlns:a="http://schemas.openxmlformats.org/drawingml/2006/main">
             <a:pPr algn="l">
+              <a:buNone/>
               <a:defRPr sz="1425" b="0" i="0">
                 <a:solidFill>
                   <a:srgbClr val="65716B"/>
@@ -7880,6 +7981,7 @@
           <a:lstStyle xmlns:a="http://schemas.openxmlformats.org/drawingml/2006/main"/>
           <a:p xmlns:a="http://schemas.openxmlformats.org/drawingml/2006/main">
             <a:pPr algn="l">
+              <a:buNone/>
               <a:defRPr sz="1125" b="1" i="0">
                 <a:solidFill>
                   <a:srgbClr val="C85034"/>
@@ -7925,6 +8027,7 @@
           <a:lstStyle xmlns:a="http://schemas.openxmlformats.org/drawingml/2006/main"/>
           <a:p xmlns:a="http://schemas.openxmlformats.org/drawingml/2006/main">
             <a:pPr algn="l">
+              <a:buNone/>
               <a:defRPr sz="2100" b="1" i="0">
                 <a:solidFill>
                   <a:srgbClr val="102F28"/>
@@ -7970,6 +8073,7 @@
           <a:lstStyle xmlns:a="http://schemas.openxmlformats.org/drawingml/2006/main"/>
           <a:p xmlns:a="http://schemas.openxmlformats.org/drawingml/2006/main">
             <a:pPr algn="l">
+              <a:buNone/>
               <a:defRPr sz="1425" b="0" i="0">
                 <a:solidFill>
                   <a:srgbClr val="65716B"/>
@@ -8049,6 +8153,7 @@
           <a:lstStyle xmlns:a="http://schemas.openxmlformats.org/drawingml/2006/main"/>
           <a:p xmlns:a="http://schemas.openxmlformats.org/drawingml/2006/main">
             <a:pPr algn="ctr">
+              <a:buNone/>
               <a:defRPr sz="1500" b="1" i="0">
                 <a:solidFill>
                   <a:srgbClr val="F3EFE5"/>
@@ -8094,6 +8199,7 @@
           <a:lstStyle xmlns:a="http://schemas.openxmlformats.org/drawingml/2006/main"/>
           <a:p xmlns:a="http://schemas.openxmlformats.org/drawingml/2006/main">
             <a:pPr algn="l">
+              <a:buNone/>
               <a:defRPr sz="1575" b="1" i="0">
                 <a:solidFill>
                   <a:srgbClr val="C85034"/>
@@ -8139,6 +8245,7 @@
           <a:lstStyle xmlns:a="http://schemas.openxmlformats.org/drawingml/2006/main"/>
           <a:p xmlns:a="http://schemas.openxmlformats.org/drawingml/2006/main">
             <a:pPr algn="l">
+              <a:buNone/>
               <a:defRPr sz="1500" b="1" i="0">
                 <a:solidFill>
                   <a:srgbClr val="102F28"/>
@@ -8184,6 +8291,7 @@
           <a:lstStyle xmlns:a="http://schemas.openxmlformats.org/drawingml/2006/main"/>
           <a:p xmlns:a="http://schemas.openxmlformats.org/drawingml/2006/main">
             <a:pPr algn="l">
+              <a:buNone/>
               <a:defRPr sz="1275" b="0" i="0">
                 <a:solidFill>
                   <a:srgbClr val="65716B"/>
@@ -8201,7 +8309,7 @@
       </p:sp>
       <p:cxnSp>
         <p:nvCxnSpPr>
-          <p:cNvPr id="58" name=""/>
+          <p:cNvPr id="116" name=""/>
           <p:cNvCxnSpPr/>
           <p:nvPr/>
         </p:nvCxnSpPr>
@@ -8251,6 +8359,7 @@
           <a:lstStyle xmlns:a="http://schemas.openxmlformats.org/drawingml/2006/main"/>
           <a:p xmlns:a="http://schemas.openxmlformats.org/drawingml/2006/main">
             <a:pPr algn="l">
+              <a:buNone/>
               <a:defRPr sz="1500" b="1" i="0">
                 <a:solidFill>
                   <a:srgbClr val="102F28"/>
@@ -8296,6 +8405,7 @@
           <a:lstStyle xmlns:a="http://schemas.openxmlformats.org/drawingml/2006/main"/>
           <a:p xmlns:a="http://schemas.openxmlformats.org/drawingml/2006/main">
             <a:pPr algn="l">
+              <a:buNone/>
               <a:defRPr sz="1275" b="0" i="0">
                 <a:solidFill>
                   <a:srgbClr val="65716B"/>
@@ -8313,7 +8423,7 @@
       </p:sp>
       <p:cxnSp>
         <p:nvCxnSpPr>
-          <p:cNvPr id="61" name=""/>
+          <p:cNvPr id="119" name=""/>
           <p:cNvCxnSpPr/>
           <p:nvPr/>
         </p:nvCxnSpPr>
@@ -8363,6 +8473,7 @@
           <a:lstStyle xmlns:a="http://schemas.openxmlformats.org/drawingml/2006/main"/>
           <a:p xmlns:a="http://schemas.openxmlformats.org/drawingml/2006/main">
             <a:pPr algn="l">
+              <a:buNone/>
               <a:defRPr sz="1500" b="1" i="0">
                 <a:solidFill>
                   <a:srgbClr val="102F28"/>
@@ -8408,6 +8519,7 @@
           <a:lstStyle xmlns:a="http://schemas.openxmlformats.org/drawingml/2006/main"/>
           <a:p xmlns:a="http://schemas.openxmlformats.org/drawingml/2006/main">
             <a:pPr algn="l">
+              <a:buNone/>
               <a:defRPr sz="1275" b="0" i="0">
                 <a:solidFill>
                   <a:srgbClr val="65716B"/>
@@ -8453,6 +8565,7 @@
           <a:lstStyle xmlns:a="http://schemas.openxmlformats.org/drawingml/2006/main"/>
           <a:p xmlns:a="http://schemas.openxmlformats.org/drawingml/2006/main">
             <a:pPr algn="l">
+              <a:buNone/>
               <a:defRPr sz="1425" b="1" i="0">
                 <a:solidFill>
                   <a:srgbClr val="1C6655"/>
@@ -8527,6 +8640,7 @@
           <a:lstStyle xmlns:a="http://schemas.openxmlformats.org/drawingml/2006/main"/>
           <a:p xmlns:a="http://schemas.openxmlformats.org/drawingml/2006/main">
             <a:pPr algn="l">
+              <a:buNone/>
               <a:defRPr sz="900" b="1" i="0">
                 <a:solidFill>
                   <a:srgbClr val="C85034"/>
@@ -8572,6 +8686,7 @@
           <a:lstStyle xmlns:a="http://schemas.openxmlformats.org/drawingml/2006/main"/>
           <a:p xmlns:a="http://schemas.openxmlformats.org/drawingml/2006/main">
             <a:pPr algn="l">
+              <a:buNone/>
               <a:defRPr sz="3225" b="0" i="0">
                 <a:solidFill>
                   <a:srgbClr val="102F28"/>
@@ -8589,7 +8704,7 @@
       </p:sp>
       <p:cxnSp>
         <p:nvCxnSpPr>
-          <p:cNvPr id="32" name=""/>
+          <p:cNvPr id="44" name=""/>
           <p:cNvCxnSpPr/>
           <p:nvPr/>
         </p:nvCxnSpPr>
@@ -8639,6 +8754,7 @@
           <a:lstStyle xmlns:a="http://schemas.openxmlformats.org/drawingml/2006/main"/>
           <a:p xmlns:a="http://schemas.openxmlformats.org/drawingml/2006/main">
             <a:pPr algn="l">
+              <a:buNone/>
               <a:defRPr sz="788" b="0" i="0">
                 <a:solidFill>
                   <a:srgbClr val="65716B"/>
@@ -8684,6 +8800,7 @@
           <a:lstStyle xmlns:a="http://schemas.openxmlformats.org/drawingml/2006/main"/>
           <a:p xmlns:a="http://schemas.openxmlformats.org/drawingml/2006/main">
             <a:pPr algn="r">
+              <a:buNone/>
               <a:defRPr sz="900" b="0" i="0">
                 <a:solidFill>
                   <a:srgbClr val="C85034"/>
@@ -8701,7 +8818,7 @@
       </p:sp>
       <p:cxnSp>
         <p:nvCxnSpPr>
-          <p:cNvPr id="35" name=""/>
+          <p:cNvPr id="47" name=""/>
           <p:cNvCxnSpPr/>
           <p:nvPr/>
         </p:nvCxnSpPr>
@@ -8850,6 +8967,7 @@
           <a:lstStyle xmlns:a="http://schemas.openxmlformats.org/drawingml/2006/main"/>
           <a:p xmlns:a="http://schemas.openxmlformats.org/drawingml/2006/main">
             <a:pPr algn="l">
+              <a:buNone/>
               <a:defRPr sz="1350" b="1" i="0">
                 <a:solidFill>
                   <a:srgbClr val="C85034"/>
@@ -8895,6 +9013,7 @@
           <a:lstStyle xmlns:a="http://schemas.openxmlformats.org/drawingml/2006/main"/>
           <a:p xmlns:a="http://schemas.openxmlformats.org/drawingml/2006/main">
             <a:pPr algn="l">
+              <a:buNone/>
               <a:defRPr sz="2175" b="1" i="0">
                 <a:solidFill>
                   <a:srgbClr val="102F28"/>
@@ -8940,6 +9059,7 @@
           <a:lstStyle xmlns:a="http://schemas.openxmlformats.org/drawingml/2006/main"/>
           <a:p xmlns:a="http://schemas.openxmlformats.org/drawingml/2006/main">
             <a:pPr algn="ctr">
+              <a:buNone/>
               <a:defRPr sz="1125" b="1" i="0">
                 <a:solidFill>
                   <a:srgbClr val="1C6655"/>
@@ -8985,6 +9105,7 @@
           <a:lstStyle xmlns:a="http://schemas.openxmlformats.org/drawingml/2006/main"/>
           <a:p xmlns:a="http://schemas.openxmlformats.org/drawingml/2006/main">
             <a:pPr algn="ctr">
+              <a:buNone/>
               <a:defRPr sz="1800" b="1" i="0">
                 <a:solidFill>
                   <a:srgbClr val="102F28"/>
@@ -9030,6 +9151,7 @@
           <a:lstStyle xmlns:a="http://schemas.openxmlformats.org/drawingml/2006/main"/>
           <a:p xmlns:a="http://schemas.openxmlformats.org/drawingml/2006/main">
             <a:pPr algn="ctr">
+              <a:buNone/>
               <a:defRPr sz="1200" b="0" i="0">
                 <a:solidFill>
                   <a:srgbClr val="65716B"/>
@@ -9075,6 +9197,7 @@
           <a:lstStyle xmlns:a="http://schemas.openxmlformats.org/drawingml/2006/main"/>
           <a:p xmlns:a="http://schemas.openxmlformats.org/drawingml/2006/main">
             <a:pPr algn="ctr">
+              <a:buNone/>
               <a:defRPr sz="1125" b="1" i="0">
                 <a:solidFill>
                   <a:srgbClr val="C85034"/>
@@ -9120,6 +9243,7 @@
           <a:lstStyle xmlns:a="http://schemas.openxmlformats.org/drawingml/2006/main"/>
           <a:p xmlns:a="http://schemas.openxmlformats.org/drawingml/2006/main">
             <a:pPr algn="ctr">
+              <a:buNone/>
               <a:defRPr sz="1800" b="1" i="0">
                 <a:solidFill>
                   <a:srgbClr val="102F28"/>
@@ -9165,6 +9289,7 @@
           <a:lstStyle xmlns:a="http://schemas.openxmlformats.org/drawingml/2006/main"/>
           <a:p xmlns:a="http://schemas.openxmlformats.org/drawingml/2006/main">
             <a:pPr algn="ctr">
+              <a:buNone/>
               <a:defRPr sz="1200" b="0" i="0">
                 <a:solidFill>
                   <a:srgbClr val="65716B"/>
@@ -9210,6 +9335,7 @@
           <a:lstStyle xmlns:a="http://schemas.openxmlformats.org/drawingml/2006/main"/>
           <a:p xmlns:a="http://schemas.openxmlformats.org/drawingml/2006/main">
             <a:pPr algn="ctr">
+              <a:buNone/>
               <a:defRPr sz="1125" b="1" i="0">
                 <a:solidFill>
                   <a:srgbClr val="102F28"/>
@@ -9255,6 +9381,7 @@
           <a:lstStyle xmlns:a="http://schemas.openxmlformats.org/drawingml/2006/main"/>
           <a:p xmlns:a="http://schemas.openxmlformats.org/drawingml/2006/main">
             <a:pPr algn="ctr">
+              <a:buNone/>
               <a:defRPr sz="1800" b="1" i="0">
                 <a:solidFill>
                   <a:srgbClr val="102F28"/>
@@ -9300,6 +9427,7 @@
           <a:lstStyle xmlns:a="http://schemas.openxmlformats.org/drawingml/2006/main"/>
           <a:p xmlns:a="http://schemas.openxmlformats.org/drawingml/2006/main">
             <a:pPr algn="ctr">
+              <a:buNone/>
               <a:defRPr sz="1200" b="0" i="0">
                 <a:solidFill>
                   <a:srgbClr val="65716B"/>
@@ -9378,6 +9506,7 @@
           <a:lstStyle xmlns:a="http://schemas.openxmlformats.org/drawingml/2006/main"/>
           <a:p xmlns:a="http://schemas.openxmlformats.org/drawingml/2006/main">
             <a:pPr algn="ctr">
+              <a:buNone/>
               <a:defRPr sz="1500" b="1" i="0">
                 <a:solidFill>
                   <a:srgbClr val="1C6655"/>
@@ -9423,6 +9552,7 @@
           <a:lstStyle xmlns:a="http://schemas.openxmlformats.org/drawingml/2006/main"/>
           <a:p xmlns:a="http://schemas.openxmlformats.org/drawingml/2006/main">
             <a:pPr algn="l">
+              <a:buNone/>
               <a:defRPr sz="1275" b="1" i="0">
                 <a:solidFill>
                   <a:srgbClr val="C85034"/>
@@ -9468,6 +9598,7 @@
           <a:lstStyle xmlns:a="http://schemas.openxmlformats.org/drawingml/2006/main"/>
           <a:p xmlns:a="http://schemas.openxmlformats.org/drawingml/2006/main">
             <a:pPr algn="l">
+              <a:buNone/>
               <a:defRPr sz="1500" b="1" i="0">
                 <a:solidFill>
                   <a:srgbClr val="102F28"/>
@@ -9513,6 +9644,7 @@
           <a:lstStyle xmlns:a="http://schemas.openxmlformats.org/drawingml/2006/main"/>
           <a:p xmlns:a="http://schemas.openxmlformats.org/drawingml/2006/main">
             <a:pPr algn="l">
+              <a:buNone/>
               <a:defRPr sz="1275" b="1" i="0">
                 <a:solidFill>
                   <a:srgbClr val="C85034"/>
@@ -9558,6 +9690,7 @@
           <a:lstStyle xmlns:a="http://schemas.openxmlformats.org/drawingml/2006/main"/>
           <a:p xmlns:a="http://schemas.openxmlformats.org/drawingml/2006/main">
             <a:pPr algn="l">
+              <a:buNone/>
               <a:defRPr sz="1500" b="1" i="0">
                 <a:solidFill>
                   <a:srgbClr val="102F28"/>
@@ -9603,6 +9736,7 @@
           <a:lstStyle xmlns:a="http://schemas.openxmlformats.org/drawingml/2006/main"/>
           <a:p xmlns:a="http://schemas.openxmlformats.org/drawingml/2006/main">
             <a:pPr algn="l">
+              <a:buNone/>
               <a:defRPr sz="1275" b="1" i="0">
                 <a:solidFill>
                   <a:srgbClr val="C85034"/>
@@ -9648,6 +9782,7 @@
           <a:lstStyle xmlns:a="http://schemas.openxmlformats.org/drawingml/2006/main"/>
           <a:p xmlns:a="http://schemas.openxmlformats.org/drawingml/2006/main">
             <a:pPr algn="l">
+              <a:buNone/>
               <a:defRPr sz="1500" b="1" i="0">
                 <a:solidFill>
                   <a:srgbClr val="102F28"/>
@@ -9693,6 +9828,7 @@
           <a:lstStyle xmlns:a="http://schemas.openxmlformats.org/drawingml/2006/main"/>
           <a:p xmlns:a="http://schemas.openxmlformats.org/drawingml/2006/main">
             <a:pPr algn="l">
+              <a:buNone/>
               <a:defRPr sz="1088" b="0" i="0">
                 <a:solidFill>
                   <a:srgbClr val="65716B"/>
@@ -9767,6 +9903,7 @@
           <a:lstStyle xmlns:a="http://schemas.openxmlformats.org/drawingml/2006/main"/>
           <a:p xmlns:a="http://schemas.openxmlformats.org/drawingml/2006/main">
             <a:pPr algn="l">
+              <a:buNone/>
               <a:defRPr sz="900" b="1" i="0">
                 <a:solidFill>
                   <a:srgbClr val="C85034"/>
@@ -9812,6 +9949,7 @@
           <a:lstStyle xmlns:a="http://schemas.openxmlformats.org/drawingml/2006/main"/>
           <a:p xmlns:a="http://schemas.openxmlformats.org/drawingml/2006/main">
             <a:pPr algn="l">
+              <a:buNone/>
               <a:defRPr sz="3225" b="0" i="0">
                 <a:solidFill>
                   <a:srgbClr val="102F28"/>
@@ -9829,7 +9967,7 @@
       </p:sp>
       <p:cxnSp>
         <p:nvCxnSpPr>
-          <p:cNvPr id="29" name=""/>
+          <p:cNvPr id="43" name=""/>
           <p:cNvCxnSpPr/>
           <p:nvPr/>
         </p:nvCxnSpPr>
@@ -9879,6 +10017,7 @@
           <a:lstStyle xmlns:a="http://schemas.openxmlformats.org/drawingml/2006/main"/>
           <a:p xmlns:a="http://schemas.openxmlformats.org/drawingml/2006/main">
             <a:pPr algn="l">
+              <a:buNone/>
               <a:defRPr sz="788" b="0" i="0">
                 <a:solidFill>
                   <a:srgbClr val="65716B"/>
@@ -9924,6 +10063,7 @@
           <a:lstStyle xmlns:a="http://schemas.openxmlformats.org/drawingml/2006/main"/>
           <a:p xmlns:a="http://schemas.openxmlformats.org/drawingml/2006/main">
             <a:pPr algn="r">
+              <a:buNone/>
               <a:defRPr sz="900" b="0" i="0">
                 <a:solidFill>
                   <a:srgbClr val="C85034"/>
@@ -9941,7 +10081,7 @@
       </p:sp>
       <p:cxnSp>
         <p:nvCxnSpPr>
-          <p:cNvPr id="32" name=""/>
+          <p:cNvPr id="46" name=""/>
           <p:cNvCxnSpPr/>
           <p:nvPr/>
         </p:nvCxnSpPr>
@@ -9963,7 +10103,7 @@
       </p:cxnSp>
       <p:cxnSp>
         <p:nvCxnSpPr>
-          <p:cNvPr id="33" name=""/>
+          <p:cNvPr id="47" name=""/>
           <p:cNvCxnSpPr/>
           <p:nvPr/>
         </p:nvCxnSpPr>
@@ -10013,6 +10153,7 @@
           <a:lstStyle xmlns:a="http://schemas.openxmlformats.org/drawingml/2006/main"/>
           <a:p xmlns:a="http://schemas.openxmlformats.org/drawingml/2006/main">
             <a:pPr algn="l">
+              <a:buNone/>
               <a:defRPr sz="1200" b="1" i="0">
                 <a:solidFill>
                   <a:srgbClr val="C85034"/>
@@ -10058,6 +10199,7 @@
           <a:lstStyle xmlns:a="http://schemas.openxmlformats.org/drawingml/2006/main"/>
           <a:p xmlns:a="http://schemas.openxmlformats.org/drawingml/2006/main">
             <a:pPr algn="l">
+              <a:buNone/>
               <a:defRPr sz="2550" b="1" i="0">
                 <a:solidFill>
                   <a:srgbClr val="1C6655"/>
@@ -10103,6 +10245,7 @@
           <a:lstStyle xmlns:a="http://schemas.openxmlformats.org/drawingml/2006/main"/>
           <a:p xmlns:a="http://schemas.openxmlformats.org/drawingml/2006/main">
             <a:pPr algn="l">
+              <a:buNone/>
               <a:defRPr sz="1050" b="1" i="0">
                 <a:solidFill>
                   <a:srgbClr val="65716B"/>
@@ -10148,6 +10291,7 @@
           <a:lstStyle xmlns:a="http://schemas.openxmlformats.org/drawingml/2006/main"/>
           <a:p xmlns:a="http://schemas.openxmlformats.org/drawingml/2006/main">
             <a:pPr algn="l">
+              <a:buNone/>
               <a:defRPr sz="1500" b="0" i="0">
                 <a:solidFill>
                   <a:srgbClr val="102F28"/>
@@ -10195,6 +10339,7 @@
           <a:lstStyle xmlns:a="http://schemas.openxmlformats.org/drawingml/2006/main"/>
           <a:p xmlns:a="http://schemas.openxmlformats.org/drawingml/2006/main">
             <a:pPr algn="l">
+              <a:buNone/>
               <a:defRPr sz="1200" b="1" i="0">
                 <a:solidFill>
                   <a:srgbClr val="C85034"/>
@@ -10240,6 +10385,7 @@
           <a:lstStyle xmlns:a="http://schemas.openxmlformats.org/drawingml/2006/main"/>
           <a:p xmlns:a="http://schemas.openxmlformats.org/drawingml/2006/main">
             <a:pPr algn="l">
+              <a:buNone/>
               <a:defRPr sz="2400" b="1" i="0">
                 <a:solidFill>
                   <a:srgbClr val="102F28"/>
@@ -10285,6 +10431,7 @@
           <a:lstStyle xmlns:a="http://schemas.openxmlformats.org/drawingml/2006/main"/>
           <a:p xmlns:a="http://schemas.openxmlformats.org/drawingml/2006/main">
             <a:pPr algn="l">
+              <a:buNone/>
               <a:defRPr sz="1050" b="1" i="0">
                 <a:solidFill>
                   <a:srgbClr val="65716B"/>
@@ -10330,6 +10477,7 @@
           <a:lstStyle xmlns:a="http://schemas.openxmlformats.org/drawingml/2006/main"/>
           <a:p xmlns:a="http://schemas.openxmlformats.org/drawingml/2006/main">
             <a:pPr algn="l">
+              <a:buNone/>
               <a:defRPr sz="1500" b="0" i="0">
                 <a:solidFill>
                   <a:srgbClr val="102F28"/>
@@ -10377,6 +10525,7 @@
           <a:lstStyle xmlns:a="http://schemas.openxmlformats.org/drawingml/2006/main"/>
           <a:p xmlns:a="http://schemas.openxmlformats.org/drawingml/2006/main">
             <a:pPr algn="l">
+              <a:buNone/>
               <a:defRPr sz="1200" b="1" i="0">
                 <a:solidFill>
                   <a:srgbClr val="C85034"/>
@@ -10422,6 +10571,7 @@
           <a:lstStyle xmlns:a="http://schemas.openxmlformats.org/drawingml/2006/main"/>
           <a:p xmlns:a="http://schemas.openxmlformats.org/drawingml/2006/main">
             <a:pPr algn="l">
+              <a:buNone/>
               <a:defRPr sz="2400" b="1" i="0">
                 <a:solidFill>
                   <a:srgbClr val="102F28"/>
@@ -10467,6 +10617,7 @@
           <a:lstStyle xmlns:a="http://schemas.openxmlformats.org/drawingml/2006/main"/>
           <a:p xmlns:a="http://schemas.openxmlformats.org/drawingml/2006/main">
             <a:pPr algn="l">
+              <a:buNone/>
               <a:defRPr sz="1050" b="1" i="0">
                 <a:solidFill>
                   <a:srgbClr val="65716B"/>
@@ -10512,6 +10663,7 @@
           <a:lstStyle xmlns:a="http://schemas.openxmlformats.org/drawingml/2006/main"/>
           <a:p xmlns:a="http://schemas.openxmlformats.org/drawingml/2006/main">
             <a:pPr algn="l">
+              <a:buNone/>
               <a:defRPr sz="1500" b="0" i="0">
                 <a:solidFill>
                   <a:srgbClr val="102F28"/>
@@ -10592,6 +10744,7 @@
           <a:lstStyle xmlns:a="http://schemas.openxmlformats.org/drawingml/2006/main"/>
           <a:p xmlns:a="http://schemas.openxmlformats.org/drawingml/2006/main">
             <a:pPr algn="ctr">
+              <a:buNone/>
               <a:defRPr sz="1575" b="1" i="0">
                 <a:solidFill>
                   <a:srgbClr val="F3EFE5"/>
@@ -10637,6 +10790,7 @@
           <a:lstStyle xmlns:a="http://schemas.openxmlformats.org/drawingml/2006/main"/>
           <a:p xmlns:a="http://schemas.openxmlformats.org/drawingml/2006/main">
             <a:pPr algn="l">
+              <a:buNone/>
               <a:defRPr sz="1575" b="1" i="0">
                 <a:solidFill>
                   <a:srgbClr val="C85034"/>
@@ -10682,6 +10836,7 @@
           <a:lstStyle xmlns:a="http://schemas.openxmlformats.org/drawingml/2006/main"/>
           <a:p xmlns:a="http://schemas.openxmlformats.org/drawingml/2006/main">
             <a:pPr algn="l">
+              <a:buNone/>
               <a:defRPr sz="1350" b="1" i="0">
                 <a:solidFill>
                   <a:srgbClr val="102F28"/>
@@ -10727,6 +10882,7 @@
           <a:lstStyle xmlns:a="http://schemas.openxmlformats.org/drawingml/2006/main"/>
           <a:p xmlns:a="http://schemas.openxmlformats.org/drawingml/2006/main">
             <a:pPr algn="l">
+              <a:buNone/>
               <a:defRPr sz="1350" b="1" i="0">
                 <a:solidFill>
                   <a:srgbClr val="102F28"/>
@@ -10772,6 +10928,7 @@
           <a:lstStyle xmlns:a="http://schemas.openxmlformats.org/drawingml/2006/main"/>
           <a:p xmlns:a="http://schemas.openxmlformats.org/drawingml/2006/main">
             <a:pPr algn="l">
+              <a:buNone/>
               <a:defRPr sz="1350" b="1" i="0">
                 <a:solidFill>
                   <a:srgbClr val="102F28"/>
@@ -10817,6 +10974,7 @@
           <a:lstStyle xmlns:a="http://schemas.openxmlformats.org/drawingml/2006/main"/>
           <a:p xmlns:a="http://schemas.openxmlformats.org/drawingml/2006/main">
             <a:pPr algn="r">
+              <a:buNone/>
               <a:defRPr sz="1350" b="1" i="0">
                 <a:solidFill>
                   <a:srgbClr val="102F28"/>

</xml_diff>